<commit_message>
Fix missing chart on slide 9 and use full name Gönül Demet
pptxgenjs wrote a dangling third axis id and invertIfNegative into the
line chart, which made PowerPoint drop the chart; animate.py now removes
both.

Co-Authored-By: Claude Opus 5.5 <noreply@anthropic.com>
Claude-Session: https://claude.ai/code/session_01V7TWfLJ2EH3hVhSrSVt6oA
</commit_message>
<xml_diff>
--- a/aybal-show/Aybal_Investor_Deck.pptx
+++ b/aybal-show/Aybal_Investor_Deck.pptx
@@ -160,7 +160,6 @@
             </a:ln>
             <a:effectLst/>
           </c:spPr>
-          <c:invertIfNegative val="0"/>
           <c:dLbls>
             <c:numFmt formatCode="#,##0" sourceLinked="0"/>
             <c:txPr>
@@ -292,7 +291,6 @@
             </a:ln>
             <a:effectLst/>
           </c:spPr>
-          <c:invertIfNegative val="0"/>
           <c:dLbls>
             <c:numFmt formatCode="#,##0" sourceLinked="0"/>
             <c:txPr>
@@ -424,7 +422,6 @@
         <c:marker val="1"/>
         <c:axId val="2094734554"/>
         <c:axId val="2094734552"/>
-        <c:axId val="2094734556"/>
       </c:lineChart>
       <c:catAx>
         <c:axId val="2094734554"/>
@@ -1642,7 +1639,7 @@
           <a:p>
             <a:r>
               <a:rPr lang="en-US" dirty="0"/>
-              <a:t>Open on the mission. Introduce yourself as founder and inventor of Aybal, and Gönül as investor relations.</a:t>
+              <a:t>Open on the mission. Introduce yourself as founder and inventor of Aybal, and Gönül Demet as investor relations.</a:t>
             </a:r>
             <a:endParaRPr lang="en-US" dirty="0"/>
           </a:p>
@@ -1818,7 +1815,7 @@
           <a:p>
             <a:r>
               <a:rPr lang="en-US" dirty="0"/>
-              <a:t>The ask: €250k on a €1.30M pre-money cap, planned close March 2027. Gönül coordinates investor conversations.</a:t>
+              <a:t>The ask: €250k on a €1.30M pre-money cap, planned close March 2027. Gönül Demet coordinates investor conversations.</a:t>
             </a:r>
             <a:endParaRPr lang="en-US" dirty="0"/>
           </a:p>
@@ -2346,7 +2343,7 @@
           <a:p>
             <a:r>
               <a:rPr lang="en-US" dirty="0"/>
-              <a:t>Close with the vision and the ask. Invite follow-up via Gönül and founders@aybal.com.</a:t>
+              <a:t>Close with the vision and the ask. Invite follow-up via Gönül Demet and founders@aybal.com.</a:t>
             </a:r>
             <a:endParaRPr lang="en-US" dirty="0"/>
           </a:p>
@@ -3822,7 +3819,7 @@
                 <a:ea typeface="Georgia" pitchFamily="34" charset="-122"/>
                 <a:cs typeface="Georgia" pitchFamily="34" charset="-120"/>
               </a:rPr>
-              <a:t>Gönül</a:t>
+              <a:t>Gönül Demet</a:t>
             </a:r>
             <a:endParaRPr lang="en-US" sz="1400" dirty="0"/>
           </a:p>
@@ -6122,7 +6119,7 @@
                 <a:ea typeface="Calibri" pitchFamily="34" charset="-122"/>
                 <a:cs typeface="Calibri" pitchFamily="34" charset="-120"/>
               </a:rPr>
-              <a:t>Investor contact: Gönül</a:t>
+              <a:t>Investor contact: Gönül Demet</a:t>
             </a:r>
             <a:endParaRPr lang="en-US" sz="1400" dirty="0"/>
           </a:p>
@@ -18824,7 +18821,7 @@
                 <a:ea typeface="Georgia" pitchFamily="34" charset="-122"/>
                 <a:cs typeface="Georgia" pitchFamily="34" charset="-120"/>
               </a:rPr>
-              <a:t>G</a:t>
+              <a:t>GD</a:t>
             </a:r>
             <a:endParaRPr lang="en-US" sz="2600" dirty="0"/>
           </a:p>
@@ -18866,7 +18863,7 @@
                 <a:ea typeface="Georgia" pitchFamily="34" charset="-122"/>
                 <a:cs typeface="Georgia" pitchFamily="34" charset="-120"/>
               </a:rPr>
-              <a:t>Gönül</a:t>
+              <a:t>Gönül Demet</a:t>
             </a:r>
             <a:endParaRPr lang="en-US" sz="1400" dirty="0"/>
           </a:p>
@@ -21398,7 +21395,7 @@
                 <a:ea typeface="Georgia" pitchFamily="34" charset="-122"/>
                 <a:cs typeface="Georgia" pitchFamily="34" charset="-120"/>
               </a:rPr>
-              <a:t>Gönül</a:t>
+              <a:t>Gönül Demet</a:t>
             </a:r>
             <a:endParaRPr lang="en-US" sz="1400" dirty="0"/>
           </a:p>

</xml_diff>

<commit_message>
Render slide 9 growth chart as an image so it shows in every viewer
Co-Authored-By: Claude Opus 5.5 <noreply@anthropic.com>
Claude-Session: https://claude.ai/code/session_01V7TWfLJ2EH3hVhSrSVt6oA
</commit_message>
<xml_diff>
--- a/aybal-show/Aybal_Investor_Deck.pptx
+++ b/aybal-show/Aybal_Investor_Deck.pptx
@@ -124,440 +124,6 @@
 </file>
 
 <file path=ppt/charts/chart1.xml><?xml version="1.0" encoding="utf-8"?>
-<c:chartSpace xmlns:c="http://schemas.openxmlformats.org/drawingml/2006/chart" xmlns:a="http://schemas.openxmlformats.org/drawingml/2006/main" xmlns:r="http://schemas.openxmlformats.org/officeDocument/2006/relationships">
-  <c:date1904 val="0"/>
-  <c:roundedCorners val="1"/>
-  <c:chart>
-    <c:autoTitleDeleted val="1"/>
-    <c:plotArea>
-      <c:layout/>
-      <c:lineChart>
-        <c:varyColors val="0"/>
-        <c:ser>
-          <c:idx val="0"/>
-          <c:order val="0"/>
-          <c:tx>
-            <c:strRef>
-              <c:f>Sheet1!$B$1</c:f>
-              <c:strCache>
-                <c:ptCount val="1"/>
-                <c:pt idx="0">
-                  <c:v>Revenue</c:v>
-                </c:pt>
-              </c:strCache>
-            </c:strRef>
-          </c:tx>
-          <c:spPr>
-            <a:solidFill>
-              <a:srgbClr val="E0859E"/>
-            </a:solidFill>
-            <a:ln w="38100" cap="flat">
-              <a:solidFill>
-                <a:srgbClr val="E0859E"/>
-              </a:solidFill>
-              <a:prstDash val="solid"/>
-              <a:round/>
-            </a:ln>
-            <a:effectLst/>
-          </c:spPr>
-          <c:dLbls>
-            <c:numFmt formatCode="#,##0" sourceLinked="0"/>
-            <c:txPr>
-              <a:bodyPr/>
-              <a:lstStyle/>
-              <a:p>
-                <a:pPr>
-                  <a:defRPr b="0" i="0" strike="noStrike" sz="1200" u="none">
-                    <a:solidFill>
-                      <a:srgbClr val="000000"/>
-                    </a:solidFill>
-                    <a:latin typeface="Arial"/>
-                  </a:defRPr>
-                </a:pPr>
-              </a:p>
-            </c:txPr>
-            <c:showLegendKey val="0"/>
-            <c:showVal val="0"/>
-            <c:showCatName val="0"/>
-            <c:showSerName val="0"/>
-            <c:showPercent val="0"/>
-            <c:showBubbleSize val="0"/>
-            <c:showLeaderLines val="0"/>
-          </c:dLbls>
-          <c:marker>
-            <c:symbol val="circle"/>
-            <c:size val="7"/>
-            <c:spPr>
-              <a:solidFill>
-                <a:srgbClr val="E0859E"/>
-              </a:solidFill>
-              <a:ln w="9525" cap="flat">
-                <a:solidFill>
-                  <a:srgbClr val="E0859E"/>
-                </a:solidFill>
-                <a:prstDash val="solid"/>
-                <a:round/>
-              </a:ln>
-              <a:effectLst/>
-            </c:spPr>
-          </c:marker>
-          <c:cat>
-            <c:multiLvlStrRef>
-              <c:f>Sheet1!$A$2:$A$8</c:f>
-              <c:multiLvlStrCache>
-                <c:ptCount val="7"/>
-                <c:lvl>
-                  <c:pt idx="0">
-                    <c:v>2027</c:v>
-                  </c:pt>
-                  <c:pt idx="1">
-                    <c:v>2028</c:v>
-                  </c:pt>
-                  <c:pt idx="2">
-                    <c:v>2029</c:v>
-                  </c:pt>
-                  <c:pt idx="3">
-                    <c:v>2030</c:v>
-                  </c:pt>
-                  <c:pt idx="4">
-                    <c:v>2031</c:v>
-                  </c:pt>
-                  <c:pt idx="5">
-                    <c:v>2032</c:v>
-                  </c:pt>
-                  <c:pt idx="6">
-                    <c:v>2033</c:v>
-                  </c:pt>
-                </c:lvl>
-              </c:multiLvlStrCache>
-            </c:multiLvlStrRef>
-          </c:cat>
-          <c:val>
-            <c:numRef>
-              <c:f>Sheet1!$B$2:$B$8</c:f>
-              <c:numCache>
-                <c:formatCode>General</c:formatCode>
-                <c:ptCount val="7"/>
-                <c:pt idx="0">
-                  <c:v>0.1</c:v>
-                </c:pt>
-                <c:pt idx="1">
-                  <c:v>0.9</c:v>
-                </c:pt>
-                <c:pt idx="2">
-                  <c:v>2.9</c:v>
-                </c:pt>
-                <c:pt idx="3">
-                  <c:v>7.4</c:v>
-                </c:pt>
-                <c:pt idx="4">
-                  <c:v>15.1</c:v>
-                </c:pt>
-                <c:pt idx="5">
-                  <c:v>26</c:v>
-                </c:pt>
-                <c:pt idx="6">
-                  <c:v>39.37</c:v>
-                </c:pt>
-              </c:numCache>
-            </c:numRef>
-          </c:val>
-          <c:smooth val="1"/>
-        </c:ser>
-        <c:ser>
-          <c:idx val="1"/>
-          <c:order val="1"/>
-          <c:tx>
-            <c:strRef>
-              <c:f>Sheet1!$C$1</c:f>
-              <c:strCache>
-                <c:ptCount val="1"/>
-                <c:pt idx="0">
-                  <c:v>Exit ARR</c:v>
-                </c:pt>
-              </c:strCache>
-            </c:strRef>
-          </c:tx>
-          <c:spPr>
-            <a:solidFill>
-              <a:srgbClr val="D4B27A"/>
-            </a:solidFill>
-            <a:ln w="38100" cap="flat">
-              <a:solidFill>
-                <a:srgbClr val="D4B27A"/>
-              </a:solidFill>
-              <a:prstDash val="solid"/>
-              <a:round/>
-            </a:ln>
-            <a:effectLst/>
-          </c:spPr>
-          <c:dLbls>
-            <c:numFmt formatCode="#,##0" sourceLinked="0"/>
-            <c:txPr>
-              <a:bodyPr/>
-              <a:lstStyle/>
-              <a:p>
-                <a:pPr>
-                  <a:defRPr b="0" i="0" strike="noStrike" sz="1200" u="none">
-                    <a:solidFill>
-                      <a:srgbClr val="000000"/>
-                    </a:solidFill>
-                    <a:latin typeface="Arial"/>
-                  </a:defRPr>
-                </a:pPr>
-              </a:p>
-            </c:txPr>
-            <c:showLegendKey val="0"/>
-            <c:showVal val="0"/>
-            <c:showCatName val="0"/>
-            <c:showSerName val="0"/>
-            <c:showPercent val="0"/>
-            <c:showBubbleSize val="0"/>
-            <c:showLeaderLines val="0"/>
-          </c:dLbls>
-          <c:marker>
-            <c:symbol val="circle"/>
-            <c:size val="7"/>
-            <c:spPr>
-              <a:solidFill>
-                <a:srgbClr val="D4B27A"/>
-              </a:solidFill>
-              <a:ln w="9525" cap="flat">
-                <a:solidFill>
-                  <a:srgbClr val="D4B27A"/>
-                </a:solidFill>
-                <a:prstDash val="solid"/>
-                <a:round/>
-              </a:ln>
-              <a:effectLst/>
-            </c:spPr>
-          </c:marker>
-          <c:cat>
-            <c:multiLvlStrRef>
-              <c:f>Sheet1!$A$2:$A$8</c:f>
-              <c:multiLvlStrCache>
-                <c:ptCount val="7"/>
-                <c:lvl>
-                  <c:pt idx="0">
-                    <c:v>2027</c:v>
-                  </c:pt>
-                  <c:pt idx="1">
-                    <c:v>2028</c:v>
-                  </c:pt>
-                  <c:pt idx="2">
-                    <c:v>2029</c:v>
-                  </c:pt>
-                  <c:pt idx="3">
-                    <c:v>2030</c:v>
-                  </c:pt>
-                  <c:pt idx="4">
-                    <c:v>2031</c:v>
-                  </c:pt>
-                  <c:pt idx="5">
-                    <c:v>2032</c:v>
-                  </c:pt>
-                  <c:pt idx="6">
-                    <c:v>2033</c:v>
-                  </c:pt>
-                </c:lvl>
-              </c:multiLvlStrCache>
-            </c:multiLvlStrRef>
-          </c:cat>
-          <c:val>
-            <c:numRef>
-              <c:f>Sheet1!$C$2:$C$8</c:f>
-              <c:numCache>
-                <c:formatCode>General</c:formatCode>
-                <c:ptCount val="7"/>
-                <c:pt idx="0">
-                  <c:v>0.3</c:v>
-                </c:pt>
-                <c:pt idx="1">
-                  <c:v>1.4</c:v>
-                </c:pt>
-                <c:pt idx="2">
-                  <c:v>4.6</c:v>
-                </c:pt>
-                <c:pt idx="3">
-                  <c:v>10.3</c:v>
-                </c:pt>
-                <c:pt idx="4">
-                  <c:v>19.2</c:v>
-                </c:pt>
-                <c:pt idx="5">
-                  <c:v>31</c:v>
-                </c:pt>
-                <c:pt idx="6">
-                  <c:v>43</c:v>
-                </c:pt>
-              </c:numCache>
-            </c:numRef>
-          </c:val>
-          <c:smooth val="1"/>
-        </c:ser>
-        <c:dLbls>
-          <c:numFmt formatCode="#,##0" sourceLinked="0"/>
-          <c:txPr>
-            <a:bodyPr/>
-            <a:lstStyle/>
-            <a:p>
-              <a:pPr>
-                <a:defRPr b="0" i="0" strike="noStrike" sz="1200" u="none">
-                  <a:solidFill>
-                    <a:srgbClr val="000000"/>
-                  </a:solidFill>
-                  <a:latin typeface="Arial"/>
-                </a:defRPr>
-              </a:pPr>
-            </a:p>
-          </c:txPr>
-          <c:showLegendKey val="0"/>
-          <c:showVal val="0"/>
-          <c:showCatName val="0"/>
-          <c:showSerName val="0"/>
-          <c:showPercent val="0"/>
-          <c:showBubbleSize val="0"/>
-          <c:showLeaderLines val="0"/>
-        </c:dLbls>
-        <c:marker val="1"/>
-        <c:axId val="2094734554"/>
-        <c:axId val="2094734552"/>
-      </c:lineChart>
-      <c:catAx>
-        <c:axId val="2094734554"/>
-        <c:scaling>
-          <c:orientation val="minMax"/>
-        </c:scaling>
-        <c:delete val="0"/>
-        <c:axPos val="b"/>
-        <c:numFmt formatCode="General" sourceLinked="1"/>
-        <c:majorTickMark val="out"/>
-        <c:minorTickMark val="none"/>
-        <c:tickLblPos val="low"/>
-        <c:spPr>
-          <a:ln w="12700" cap="flat">
-            <a:noFill/>
-            <a:prstDash val="solid"/>
-            <a:round/>
-          </a:ln>
-        </c:spPr>
-        <c:txPr>
-          <a:bodyPr/>
-          <a:lstStyle/>
-          <a:p>
-            <a:pPr>
-              <a:defRPr sz="1100" b="0" i="0" u="none" strike="noStrike">
-                <a:solidFill>
-                  <a:srgbClr val="B7A79E"/>
-                </a:solidFill>
-                <a:latin typeface="Arial"/>
-              </a:defRPr>
-            </a:pPr>
-            <a:endParaRPr lang="en-US"/>
-          </a:p>
-        </c:txPr>
-        <c:crossAx val="2094734552"/>
-        <c:crosses val="autoZero"/>
-        <c:auto val="1"/>
-        <c:lblAlgn val="ctr"/>
-        <c:noMultiLvlLbl val="1"/>
-      </c:catAx>
-      <c:valAx>
-        <c:axId val="2094734552"/>
-        <c:scaling>
-          <c:orientation val="minMax"/>
-          <c:max val="50"/>
-          <c:min val="0"/>
-        </c:scaling>
-        <c:delete val="0"/>
-        <c:axPos val="l"/>
-        <c:majorGridlines>
-          <c:spPr>
-            <a:ln w="9525" cap="flat">
-              <a:solidFill>
-                <a:srgbClr val="4A2232"/>
-              </a:solidFill>
-              <a:prstDash val="solid"/>
-              <a:round/>
-            </a:ln>
-          </c:spPr>
-        </c:majorGridlines>
-        <c:numFmt formatCode="&quot;€&quot;0&quot;M&quot;" sourceLinked="0"/>
-        <c:majorTickMark val="out"/>
-        <c:minorTickMark val="none"/>
-        <c:tickLblPos val="nextTo"/>
-        <c:spPr>
-          <a:ln w="12700" cap="flat">
-            <a:noFill/>
-            <a:prstDash val="solid"/>
-            <a:round/>
-          </a:ln>
-        </c:spPr>
-        <c:txPr>
-          <a:bodyPr/>
-          <a:lstStyle/>
-          <a:p>
-            <a:pPr>
-              <a:defRPr sz="1000" b="0" i="0" u="none" strike="noStrike">
-                <a:solidFill>
-                  <a:srgbClr val="B7A79E"/>
-                </a:solidFill>
-                <a:latin typeface="Arial"/>
-              </a:defRPr>
-            </a:pPr>
-            <a:endParaRPr lang="en-US"/>
-          </a:p>
-        </c:txPr>
-        <c:crossAx val="2094734554"/>
-        <c:crosses val="autoZero"/>
-        <c:crossBetween val="between"/>
-        <c:majorUnit val="10"/>
-      </c:valAx>
-      <c:spPr>
-        <a:solidFill>
-          <a:srgbClr val="2E0B18"/>
-        </a:solidFill>
-        <a:ln>
-          <a:noFill/>
-        </a:ln>
-        <a:effectLst/>
-      </c:spPr>
-    </c:plotArea>
-    <c:legend>
-      <c:legendPos val="t"/>
-      <c:overlay val="0"/>
-      <c:txPr>
-        <a:bodyPr/>
-        <a:lstStyle/>
-        <a:p>
-          <a:pPr>
-            <a:defRPr sz="1100">
-              <a:solidFill>
-                <a:srgbClr val="E9DFD3"/>
-              </a:solidFill>
-            </a:defRPr>
-          </a:pPr>
-          <a:endParaRPr lang="en-US"/>
-        </a:p>
-      </c:txPr>
-    </c:legend>
-    <c:plotVisOnly val="1"/>
-    <c:dispBlanksAs val="span"/>
-  </c:chart>
-  <c:spPr>
-    <a:noFill/>
-    <a:ln>
-      <a:noFill/>
-    </a:ln>
-    <a:effectLst/>
-  </c:spPr>
-  <c:externalData r:id="rId1">
-    <c:autoUpdate val="0"/>
-  </c:externalData>
-</c:chartSpace>
-</file>
-
-<file path=ppt/charts/chart2.xml><?xml version="1.0" encoding="utf-8"?>
 <c:chartSpace xmlns:c="http://schemas.openxmlformats.org/drawingml/2006/chart" xmlns:a="http://schemas.openxmlformats.org/drawingml/2006/main" xmlns:r="http://schemas.openxmlformats.org/officeDocument/2006/relationships">
   <c:date1904 val="0"/>
   <c:roundedCorners val="1"/>
@@ -947,7 +513,7 @@
 </c:chartSpace>
 </file>
 
-<file path=ppt/charts/chart3.xml><?xml version="1.0" encoding="utf-8"?>
+<file path=ppt/charts/chart2.xml><?xml version="1.0" encoding="utf-8"?>
 <c:chartSpace xmlns:c="http://schemas.openxmlformats.org/drawingml/2006/chart" xmlns:a="http://schemas.openxmlformats.org/drawingml/2006/main" xmlns:r="http://schemas.openxmlformats.org/officeDocument/2006/relationships">
   <c:date1904 val="0"/>
   <c:roundedCorners val="1"/>
@@ -38111,22 +37677,30 @@
           </a:p>
         </p:txBody>
       </p:sp>
-      <p:graphicFrame>
-        <p:nvGraphicFramePr>
-          <p:cNvPr id="7" name="anim:wipeL:500:2800" descr=""/>
-          <p:cNvGraphicFramePr/>
+      <p:pic>
+        <p:nvPicPr>
+          <p:cNvPr id="7" name="anim:wipeL:500:2800" descr="Venture scenario: revenue and exit ARR 2027–2033">    </p:cNvPr>
+          <p:cNvPicPr>
+            <a:picLocks noChangeAspect="1"/>
+          </p:cNvPicPr>
           <p:nvPr/>
-        </p:nvGraphicFramePr>
-        <p:xfrm>
-          <a:off x="502920" y="1645920"/>
-          <a:ext cx="7315200" cy="4526280"/>
-        </p:xfrm>
-        <a:graphic xmlns:a="http://schemas.openxmlformats.org/drawingml/2006/main">
-          <a:graphicData uri="http://schemas.openxmlformats.org/drawingml/2006/chart">
-            <c:chart xmlns:c="http://schemas.openxmlformats.org/drawingml/2006/chart" r:id="rId1"/>
-          </a:graphicData>
-        </a:graphic>
-      </p:graphicFrame>
+        </p:nvPicPr>
+        <p:blipFill>
+          <a:blip r:embed="rId1"/>
+          <a:stretch>
+            <a:fillRect/>
+          </a:stretch>
+        </p:blipFill>
+        <p:spPr>
+          <a:xfrm>
+            <a:off x="502920" y="1645920"/>
+            <a:ext cx="7315200" cy="4526280"/>
+          </a:xfrm>
+          <a:prstGeom prst="rect">
+            <a:avLst/>
+          </a:prstGeom>
+        </p:spPr>
+      </p:pic>
       <p:sp>
         <p:nvSpPr>
           <p:cNvPr id="8" name="anim:fade:600"/>
@@ -39015,9 +38589,6 @@
     <p:bldLst>
       <p:bldP spid="2" grpId="0" animBg="1"/>
       <p:bldP spid="3" grpId="0" animBg="1"/>
-      <p:bldGraphic spid="7" grpId="0">
-        <p:bldAsOne/>
-      </p:bldGraphic>
       <p:bldP spid="8" grpId="0" animBg="1"/>
       <p:bldP spid="9" grpId="0" animBg="1"/>
       <p:bldP spid="10" grpId="0" animBg="1"/>

</xml_diff>